<commit_message>
Slide and BC updates
</commit_message>
<xml_diff>
--- a/e61 Projects/Presentations/Discusant RBA Housing TTPI 2026.pptx
+++ b/e61 Projects/Presentations/Discusant RBA Housing TTPI 2026.pptx
@@ -19,7 +19,7 @@
     <p:sldId id="2147140431" r:id="rId10"/>
   </p:sldIdLst>
   <p:sldSz cx="12192000" cy="6858000"/>
-  <p:notesSz cx="6858000" cy="9144000"/>
+  <p:notesSz cx="7099300" cy="9385300"/>
   <p:custDataLst>
     <p:tags r:id="rId13"/>
   </p:custDataLst>
@@ -192,14 +192,14 @@
         <p:spPr>
           <a:xfrm>
             <a:off x="0" y="0"/>
-            <a:ext cx="2971800" cy="458788"/>
-          </a:xfrm>
-          <a:prstGeom prst="rect">
-            <a:avLst/>
-          </a:prstGeom>
-        </p:spPr>
-        <p:txBody>
-          <a:bodyPr vert="horz" lIns="91440" tIns="45720" rIns="91440" bIns="45720" rtlCol="0"/>
+            <a:ext cx="3076363" cy="470895"/>
+          </a:xfrm>
+          <a:prstGeom prst="rect">
+            <a:avLst/>
+          </a:prstGeom>
+        </p:spPr>
+        <p:txBody>
+          <a:bodyPr vert="horz" lIns="94192" tIns="47096" rIns="94192" bIns="47096" rtlCol="0"/>
           <a:lstStyle>
             <a:lvl1pPr algn="l">
               <a:defRPr sz="1200"/>
@@ -228,15 +228,15 @@
         </p:nvSpPr>
         <p:spPr>
           <a:xfrm>
-            <a:off x="3884613" y="0"/>
-            <a:ext cx="2971800" cy="458788"/>
-          </a:xfrm>
-          <a:prstGeom prst="rect">
-            <a:avLst/>
-          </a:prstGeom>
-        </p:spPr>
-        <p:txBody>
-          <a:bodyPr vert="horz" lIns="91440" tIns="45720" rIns="91440" bIns="45720" rtlCol="0"/>
+            <a:off x="4021294" y="0"/>
+            <a:ext cx="3076363" cy="470895"/>
+          </a:xfrm>
+          <a:prstGeom prst="rect">
+            <a:avLst/>
+          </a:prstGeom>
+        </p:spPr>
+        <p:txBody>
+          <a:bodyPr vert="horz" lIns="94192" tIns="47096" rIns="94192" bIns="47096" rtlCol="0"/>
           <a:lstStyle>
             <a:lvl1pPr algn="r">
               <a:defRPr sz="1200"/>
@@ -245,7 +245,7 @@
           <a:p>
             <a:fld id="{60F87968-E7C3-4FA2-86D7-7CFDDCA2896A}" type="datetimeFigureOut">
               <a:rPr lang="en-US" smtClean="0"/>
-              <a:t>7/28/2026</a:t>
+              <a:t>29-Jul-26</a:t>
             </a:fld>
             <a:endParaRPr lang="en-US"/>
           </a:p>
@@ -269,15 +269,15 @@
         </p:nvSpPr>
         <p:spPr>
           <a:xfrm>
-            <a:off x="0" y="8685213"/>
-            <a:ext cx="2971800" cy="458787"/>
-          </a:xfrm>
-          <a:prstGeom prst="rect">
-            <a:avLst/>
-          </a:prstGeom>
-        </p:spPr>
-        <p:txBody>
-          <a:bodyPr vert="horz" lIns="91440" tIns="45720" rIns="91440" bIns="45720" rtlCol="0" anchor="b"/>
+            <a:off x="0" y="8914407"/>
+            <a:ext cx="3076363" cy="470894"/>
+          </a:xfrm>
+          <a:prstGeom prst="rect">
+            <a:avLst/>
+          </a:prstGeom>
+        </p:spPr>
+        <p:txBody>
+          <a:bodyPr vert="horz" lIns="94192" tIns="47096" rIns="94192" bIns="47096" rtlCol="0" anchor="b"/>
           <a:lstStyle>
             <a:lvl1pPr algn="l">
               <a:defRPr sz="1200"/>
@@ -306,15 +306,15 @@
         </p:nvSpPr>
         <p:spPr>
           <a:xfrm>
-            <a:off x="3884613" y="8685213"/>
-            <a:ext cx="2971800" cy="458787"/>
-          </a:xfrm>
-          <a:prstGeom prst="rect">
-            <a:avLst/>
-          </a:prstGeom>
-        </p:spPr>
-        <p:txBody>
-          <a:bodyPr vert="horz" lIns="91440" tIns="45720" rIns="91440" bIns="45720" rtlCol="0" anchor="b"/>
+            <a:off x="4021294" y="8914407"/>
+            <a:ext cx="3076363" cy="470894"/>
+          </a:xfrm>
+          <a:prstGeom prst="rect">
+            <a:avLst/>
+          </a:prstGeom>
+        </p:spPr>
+        <p:txBody>
+          <a:bodyPr vert="horz" lIns="94192" tIns="47096" rIns="94192" bIns="47096" rtlCol="0" anchor="b"/>
           <a:lstStyle>
             <a:lvl1pPr algn="r">
               <a:defRPr sz="1200"/>
@@ -375,14 +375,14 @@
         <p:spPr>
           <a:xfrm>
             <a:off x="0" y="0"/>
-            <a:ext cx="2971800" cy="458788"/>
-          </a:xfrm>
-          <a:prstGeom prst="rect">
-            <a:avLst/>
-          </a:prstGeom>
-        </p:spPr>
-        <p:txBody>
-          <a:bodyPr vert="horz" lIns="91440" tIns="45720" rIns="91440" bIns="45720" rtlCol="0"/>
+            <a:ext cx="3076363" cy="470895"/>
+          </a:xfrm>
+          <a:prstGeom prst="rect">
+            <a:avLst/>
+          </a:prstGeom>
+        </p:spPr>
+        <p:txBody>
+          <a:bodyPr vert="horz" lIns="94192" tIns="47096" rIns="94192" bIns="47096" rtlCol="0"/>
           <a:lstStyle>
             <a:lvl1pPr algn="l">
               <a:defRPr sz="1200"/>
@@ -405,15 +405,15 @@
         </p:nvSpPr>
         <p:spPr>
           <a:xfrm>
-            <a:off x="3884613" y="0"/>
-            <a:ext cx="2971800" cy="458788"/>
-          </a:xfrm>
-          <a:prstGeom prst="rect">
-            <a:avLst/>
-          </a:prstGeom>
-        </p:spPr>
-        <p:txBody>
-          <a:bodyPr vert="horz" lIns="91440" tIns="45720" rIns="91440" bIns="45720" rtlCol="0"/>
+            <a:off x="4021294" y="0"/>
+            <a:ext cx="3076363" cy="470895"/>
+          </a:xfrm>
+          <a:prstGeom prst="rect">
+            <a:avLst/>
+          </a:prstGeom>
+        </p:spPr>
+        <p:txBody>
+          <a:bodyPr vert="horz" lIns="94192" tIns="47096" rIns="94192" bIns="47096" rtlCol="0"/>
           <a:lstStyle>
             <a:lvl1pPr algn="r">
               <a:defRPr sz="1200"/>
@@ -422,7 +422,7 @@
           <a:p>
             <a:fld id="{B416A7BE-E113-476D-8DE0-A6138461ACE1}" type="datetimeFigureOut">
               <a:rPr lang="en-US" smtClean="0"/>
-              <a:t>7/28/2026</a:t>
+              <a:t>29-Jul-26</a:t>
             </a:fld>
             <a:endParaRPr lang="en-US"/>
           </a:p>
@@ -440,8 +440,8 @@
         </p:nvSpPr>
         <p:spPr>
           <a:xfrm>
-            <a:off x="685800" y="1143000"/>
-            <a:ext cx="5486400" cy="3086100"/>
+            <a:off x="735013" y="1173163"/>
+            <a:ext cx="5629275" cy="3167062"/>
           </a:xfrm>
           <a:prstGeom prst="rect">
             <a:avLst/>
@@ -454,7 +454,7 @@
           </a:ln>
         </p:spPr>
         <p:txBody>
-          <a:bodyPr vert="horz" lIns="91440" tIns="45720" rIns="91440" bIns="45720" rtlCol="0" anchor="ctr"/>
+          <a:bodyPr vert="horz" lIns="94192" tIns="47096" rIns="94192" bIns="47096" rtlCol="0" anchor="ctr"/>
           <a:lstStyle/>
           <a:p>
             <a:endParaRPr lang="en-US"/>
@@ -473,15 +473,15 @@
         </p:nvSpPr>
         <p:spPr>
           <a:xfrm>
-            <a:off x="685800" y="4400550"/>
-            <a:ext cx="5486400" cy="3600450"/>
-          </a:xfrm>
-          <a:prstGeom prst="rect">
-            <a:avLst/>
-          </a:prstGeom>
-        </p:spPr>
-        <p:txBody>
-          <a:bodyPr vert="horz" lIns="91440" tIns="45720" rIns="91440" bIns="45720" rtlCol="0"/>
+            <a:off x="709930" y="4516676"/>
+            <a:ext cx="5679440" cy="3695462"/>
+          </a:xfrm>
+          <a:prstGeom prst="rect">
+            <a:avLst/>
+          </a:prstGeom>
+        </p:spPr>
+        <p:txBody>
+          <a:bodyPr vert="horz" lIns="94192" tIns="47096" rIns="94192" bIns="47096" rtlCol="0"/>
           <a:lstStyle/>
           <a:p>
             <a:pPr lvl="0"/>
@@ -532,15 +532,15 @@
         </p:nvSpPr>
         <p:spPr>
           <a:xfrm>
-            <a:off x="0" y="8685213"/>
-            <a:ext cx="2971800" cy="458787"/>
-          </a:xfrm>
-          <a:prstGeom prst="rect">
-            <a:avLst/>
-          </a:prstGeom>
-        </p:spPr>
-        <p:txBody>
-          <a:bodyPr vert="horz" lIns="91440" tIns="45720" rIns="91440" bIns="45720" rtlCol="0" anchor="b"/>
+            <a:off x="0" y="8914407"/>
+            <a:ext cx="3076363" cy="470894"/>
+          </a:xfrm>
+          <a:prstGeom prst="rect">
+            <a:avLst/>
+          </a:prstGeom>
+        </p:spPr>
+        <p:txBody>
+          <a:bodyPr vert="horz" lIns="94192" tIns="47096" rIns="94192" bIns="47096" rtlCol="0" anchor="b"/>
           <a:lstStyle>
             <a:lvl1pPr algn="l">
               <a:defRPr sz="1200"/>
@@ -563,15 +563,15 @@
         </p:nvSpPr>
         <p:spPr>
           <a:xfrm>
-            <a:off x="3884613" y="8685213"/>
-            <a:ext cx="2971800" cy="458787"/>
-          </a:xfrm>
-          <a:prstGeom prst="rect">
-            <a:avLst/>
-          </a:prstGeom>
-        </p:spPr>
-        <p:txBody>
-          <a:bodyPr vert="horz" lIns="91440" tIns="45720" rIns="91440" bIns="45720" rtlCol="0" anchor="b"/>
+            <a:off x="4021294" y="8914407"/>
+            <a:ext cx="3076363" cy="470894"/>
+          </a:xfrm>
+          <a:prstGeom prst="rect">
+            <a:avLst/>
+          </a:prstGeom>
+        </p:spPr>
+        <p:txBody>
+          <a:bodyPr vert="horz" lIns="94192" tIns="47096" rIns="94192" bIns="47096" rtlCol="0" anchor="b"/>
           <a:lstStyle>
             <a:lvl1pPr algn="r">
               <a:defRPr sz="1200"/>
@@ -20036,36 +20036,24 @@
             <p:ph type="ctrTitle"/>
           </p:nvPr>
         </p:nvSpPr>
-        <p:spPr/>
+        <p:spPr>
+          <a:xfrm>
+            <a:off x="1149093" y="805544"/>
+            <a:ext cx="10106736" cy="3429000"/>
+          </a:xfrm>
+        </p:spPr>
         <p:txBody>
           <a:bodyPr/>
           <a:lstStyle/>
           <a:p>
-            <a:endParaRPr lang="en-AU" dirty="0"/>
-          </a:p>
-        </p:txBody>
-      </p:sp>
-      <p:sp>
-        <p:nvSpPr>
-          <p:cNvPr id="8" name="Subtitle 7">
-            <a:extLst>
-              <a:ext uri="{FF2B5EF4-FFF2-40B4-BE49-F238E27FC236}">
-                <a16:creationId xmlns:a16="http://schemas.microsoft.com/office/drawing/2014/main" id="{8BAD583D-414C-8D2B-DA03-8F81A23522E2}"/>
-              </a:ext>
-            </a:extLst>
-          </p:cNvPr>
-          <p:cNvSpPr>
-            <a:spLocks noGrp="1"/>
-          </p:cNvSpPr>
-          <p:nvPr>
-            <p:ph type="subTitle" idx="1"/>
-          </p:nvPr>
-        </p:nvSpPr>
-        <p:spPr/>
-        <p:txBody>
-          <a:bodyPr/>
-          <a:lstStyle/>
-          <a:p>
+            <a:r>
+              <a:rPr lang="en-AU" dirty="0"/>
+              <a:t>Discussion: </a:t>
+            </a:r>
+            <a:r>
+              <a:rPr lang="en-US" dirty="0"/>
+              <a:t>Insights From New Data on Australian Housing Investors</a:t>
+            </a:r>
             <a:endParaRPr lang="en-AU" dirty="0"/>
           </a:p>
         </p:txBody>
@@ -20360,12 +20348,12 @@
           </a:bodyPr>
           <a:lstStyle/>
           <a:p>
-            <a:pPr marL="285750" indent="-285750">
+            <a:pPr marL="342900" indent="-342900">
               <a:spcAft>
                 <a:spcPts val="600"/>
               </a:spcAft>
-              <a:buFont typeface="Arial" panose="020B0604020202020204" pitchFamily="34" charset="0"/>
-              <a:buChar char="•"/>
+              <a:buFont typeface="+mj-lt"/>
+              <a:buAutoNum type="arabicPeriod"/>
             </a:pPr>
             <a:r>
               <a:rPr lang="en-AU" sz="1600" dirty="0">
@@ -20379,12 +20367,12 @@
             </a:r>
           </a:p>
           <a:p>
-            <a:pPr marL="285750" indent="-285750">
+            <a:pPr marL="342900" indent="-342900">
               <a:spcAft>
                 <a:spcPts val="600"/>
               </a:spcAft>
-              <a:buFont typeface="Arial" panose="020B0604020202020204" pitchFamily="34" charset="0"/>
-              <a:buChar char="•"/>
+              <a:buFont typeface="+mj-lt"/>
+              <a:buAutoNum type="arabicPeriod"/>
             </a:pPr>
             <a:r>
               <a:rPr lang="en-AU" sz="1600" dirty="0">
@@ -20398,12 +20386,12 @@
             </a:r>
           </a:p>
           <a:p>
-            <a:pPr marL="285750" indent="-285750">
+            <a:pPr marL="342900" indent="-342900">
               <a:spcAft>
                 <a:spcPts val="600"/>
               </a:spcAft>
-              <a:buFont typeface="Arial" panose="020B0604020202020204" pitchFamily="34" charset="0"/>
-              <a:buChar char="•"/>
+              <a:buFont typeface="+mj-lt"/>
+              <a:buAutoNum type="arabicPeriod"/>
             </a:pPr>
             <a:r>
               <a:rPr lang="en-AU" sz="1600" dirty="0">
@@ -20417,12 +20405,12 @@
             </a:r>
           </a:p>
           <a:p>
-            <a:pPr marL="285750" indent="-285750">
+            <a:pPr marL="342900" indent="-342900">
               <a:spcAft>
                 <a:spcPts val="600"/>
               </a:spcAft>
-              <a:buFont typeface="Arial" panose="020B0604020202020204" pitchFamily="34" charset="0"/>
-              <a:buChar char="•"/>
+              <a:buFont typeface="+mj-lt"/>
+              <a:buAutoNum type="arabicPeriod"/>
             </a:pPr>
             <a:r>
               <a:rPr lang="en-AU" sz="1600" dirty="0">
@@ -20436,12 +20424,12 @@
             </a:r>
           </a:p>
           <a:p>
-            <a:pPr marL="285750" indent="-285750">
+            <a:pPr marL="342900" indent="-342900">
               <a:spcAft>
                 <a:spcPts val="600"/>
               </a:spcAft>
-              <a:buFont typeface="Arial" panose="020B0604020202020204" pitchFamily="34" charset="0"/>
-              <a:buChar char="•"/>
+              <a:buFont typeface="+mj-lt"/>
+              <a:buAutoNum type="arabicPeriod"/>
             </a:pPr>
             <a:r>
               <a:rPr lang="en-AU" sz="1600" dirty="0">
@@ -20455,12 +20443,12 @@
             </a:r>
           </a:p>
           <a:p>
-            <a:pPr marL="285750" indent="-285750">
+            <a:pPr marL="342900" indent="-342900">
               <a:spcAft>
                 <a:spcPts val="600"/>
               </a:spcAft>
-              <a:buFont typeface="Arial" panose="020B0604020202020204" pitchFamily="34" charset="0"/>
-              <a:buChar char="•"/>
+              <a:buFont typeface="+mj-lt"/>
+              <a:buAutoNum type="arabicPeriod"/>
             </a:pPr>
             <a:r>
               <a:rPr lang="en-AU" sz="1600" dirty="0">
@@ -20474,12 +20462,12 @@
             </a:r>
           </a:p>
           <a:p>
-            <a:pPr marL="285750" indent="-285750">
+            <a:pPr marL="342900" indent="-342900">
               <a:spcAft>
                 <a:spcPts val="600"/>
               </a:spcAft>
-              <a:buFont typeface="Arial" panose="020B0604020202020204" pitchFamily="34" charset="0"/>
-              <a:buChar char="•"/>
+              <a:buFont typeface="+mj-lt"/>
+              <a:buAutoNum type="arabicPeriod"/>
             </a:pPr>
             <a:r>
               <a:rPr lang="en-AU" sz="1600" dirty="0">
@@ -21071,7 +21059,7 @@
         <p:spPr>
           <a:xfrm>
             <a:off x="370417" y="1915554"/>
-            <a:ext cx="10903190" cy="723275"/>
+            <a:ext cx="10903190" cy="1077218"/>
           </a:xfrm>
           <a:prstGeom prst="rect">
             <a:avLst/>
@@ -21083,6 +21071,32 @@
             <a:spAutoFit/>
           </a:bodyPr>
           <a:lstStyle/>
+          <a:p>
+            <a:pPr marL="285750" indent="-285750">
+              <a:spcAft>
+                <a:spcPts val="600"/>
+              </a:spcAft>
+              <a:buFont typeface="Arial" panose="020B0604020202020204" pitchFamily="34" charset="0"/>
+              <a:buChar char="•"/>
+            </a:pPr>
+            <a:r>
+              <a:rPr lang="en-AU" dirty="0"/>
+              <a:t>Highlighting the joint factors that explain default risk.</a:t>
+            </a:r>
+          </a:p>
+          <a:p>
+            <a:pPr marL="285750" indent="-285750">
+              <a:spcAft>
+                <a:spcPts val="600"/>
+              </a:spcAft>
+              <a:buFont typeface="Arial" panose="020B0604020202020204" pitchFamily="34" charset="0"/>
+              <a:buChar char="•"/>
+            </a:pPr>
+            <a:r>
+              <a:rPr lang="en-AU" dirty="0"/>
+              <a:t>Likely, more richly describing the joint distribution of factors.</a:t>
+            </a:r>
+          </a:p>
           <a:p>
             <a:pPr marL="285750" indent="-285750">
               <a:spcAft>
@@ -21094,19 +21108,6 @@
             <a:r>
               <a:rPr lang="en-AU" dirty="0"/>
               <a:t>Simulating responses to adverse shocks.</a:t>
-            </a:r>
-          </a:p>
-          <a:p>
-            <a:pPr marL="285750" indent="-285750">
-              <a:spcAft>
-                <a:spcPts val="600"/>
-              </a:spcAft>
-              <a:buFont typeface="Arial" panose="020B0604020202020204" pitchFamily="34" charset="0"/>
-              <a:buChar char="•"/>
-            </a:pPr>
-            <a:r>
-              <a:rPr lang="en-AU" dirty="0"/>
-              <a:t>Likely, more richly describing the joint distribution of factors.</a:t>
             </a:r>
           </a:p>
         </p:txBody>
@@ -21767,10 +21768,10 @@
       </p:sp>
       <p:pic>
         <p:nvPicPr>
-          <p:cNvPr id="13" name="Picture 12">
-            <a:extLst>
-              <a:ext uri="{FF2B5EF4-FFF2-40B4-BE49-F238E27FC236}">
-                <a16:creationId xmlns:a16="http://schemas.microsoft.com/office/drawing/2014/main" id="{F05D41E7-EA4B-3814-D89D-AE7029CC9559}"/>
+          <p:cNvPr id="7" name="Picture 6">
+            <a:extLst>
+              <a:ext uri="{FF2B5EF4-FFF2-40B4-BE49-F238E27FC236}">
+                <a16:creationId xmlns:a16="http://schemas.microsoft.com/office/drawing/2014/main" id="{8DD4A2A8-EA86-14EF-BF47-1DD6F69B0C74}"/>
               </a:ext>
             </a:extLst>
           </p:cNvPr>
@@ -21793,8 +21794,8 @@
         </p:blipFill>
         <p:spPr>
           <a:xfrm>
-            <a:off x="5795802" y="2829562"/>
-            <a:ext cx="5151120" cy="3571444"/>
+            <a:off x="6096000" y="2617184"/>
+            <a:ext cx="4583740" cy="4221866"/>
           </a:xfrm>
           <a:prstGeom prst="rect">
             <a:avLst/>
@@ -21989,7 +21990,7 @@
                                           </p:stCondLst>
                                         </p:cTn>
                                         <p:tgtEl>
-                                          <p:spTgt spid="13"/>
+                                          <p:spTgt spid="7"/>
                                         </p:tgtEl>
                                         <p:attrNameLst>
                                           <p:attrName>style.visibility</p:attrName>
@@ -24668,6 +24669,15 @@
 </file>
 
 <file path=customXml/item2.xml><?xml version="1.0" encoding="utf-8"?>
+<?mso-contentType ?>
+<FormTemplates xmlns="http://schemas.microsoft.com/sharepoint/v3/contenttype/forms">
+  <Display>DocumentLibraryForm</Display>
+  <Edit>DocumentLibraryForm</Edit>
+  <New>DocumentLibraryForm</New>
+</FormTemplates>
+</file>
+
+<file path=customXml/item3.xml><?xml version="1.0" encoding="utf-8"?>
 <ct:contentTypeSchema xmlns:ct="http://schemas.microsoft.com/office/2006/metadata/contentType" xmlns:ma="http://schemas.microsoft.com/office/2006/metadata/properties/metaAttributes" ct:_="" ma:_="" ma:contentTypeName="Document" ma:contentTypeID="0x010100E38A1619F266734FBC2B48FB95398739" ma:contentTypeVersion="18" ma:contentTypeDescription="Create a new document." ma:contentTypeScope="" ma:versionID="8dc4163b27f0ec44a22c6d7358323f5f">
   <xsd:schema xmlns:xsd="http://www.w3.org/2001/XMLSchema" xmlns:xs="http://www.w3.org/2001/XMLSchema" xmlns:p="http://schemas.microsoft.com/office/2006/metadata/properties" xmlns:ns2="aa802c90-64f7-4260-a678-c5c09559402a" xmlns:ns3="d4025935-85eb-43e8-ab32-734675053e7f" targetNamespace="http://schemas.microsoft.com/office/2006/metadata/properties" ma:root="true" ma:fieldsID="a1176a965c39d1ac1c7d6ef690b32559" ns2:_="" ns3:_="">
     <xsd:import namespace="aa802c90-64f7-4260-a678-c5c09559402a"/>
@@ -24922,33 +24932,32 @@
 </ct:contentTypeSchema>
 </file>
 
-<file path=customXml/item3.xml><?xml version="1.0" encoding="utf-8"?>
-<?mso-contentType ?>
-<FormTemplates xmlns="http://schemas.microsoft.com/sharepoint/v3/contenttype/forms">
-  <Display>DocumentLibraryForm</Display>
-  <Edit>DocumentLibraryForm</Edit>
-  <New>DocumentLibraryForm</New>
-</FormTemplates>
-</file>
-
 <file path=customXml/itemProps1.xml><?xml version="1.0" encoding="utf-8"?>
 <ds:datastoreItem xmlns:ds="http://schemas.openxmlformats.org/officeDocument/2006/customXml" ds:itemID="{8E36B762-179B-48EA-90B2-E74079BA15DE}">
   <ds:schemaRefs>
+    <ds:schemaRef ds:uri="http://purl.org/dc/elements/1.1/"/>
+    <ds:schemaRef ds:uri="aa802c90-64f7-4260-a678-c5c09559402a"/>
+    <ds:schemaRef ds:uri="d4025935-85eb-43e8-ab32-734675053e7f"/>
+    <ds:schemaRef ds:uri="http://schemas.microsoft.com/office/infopath/2007/PartnerControls"/>
     <ds:schemaRef ds:uri="http://schemas.microsoft.com/office/2006/documentManagement/types"/>
+    <ds:schemaRef ds:uri="http://purl.org/dc/dcmitype/"/>
+    <ds:schemaRef ds:uri="http://www.w3.org/XML/1998/namespace"/>
+    <ds:schemaRef ds:uri="http://purl.org/dc/terms/"/>
     <ds:schemaRef ds:uri="http://schemas.openxmlformats.org/package/2006/metadata/core-properties"/>
-    <ds:schemaRef ds:uri="http://purl.org/dc/terms/"/>
-    <ds:schemaRef ds:uri="aa802c90-64f7-4260-a678-c5c09559402a"/>
-    <ds:schemaRef ds:uri="http://purl.org/dc/elements/1.1/"/>
     <ds:schemaRef ds:uri="http://schemas.microsoft.com/office/2006/metadata/properties"/>
-    <ds:schemaRef ds:uri="http://www.w3.org/XML/1998/namespace"/>
-    <ds:schemaRef ds:uri="http://schemas.microsoft.com/office/infopath/2007/PartnerControls"/>
-    <ds:schemaRef ds:uri="d4025935-85eb-43e8-ab32-734675053e7f"/>
-    <ds:schemaRef ds:uri="http://purl.org/dc/dcmitype/"/>
   </ds:schemaRefs>
 </ds:datastoreItem>
 </file>
 
 <file path=customXml/itemProps2.xml><?xml version="1.0" encoding="utf-8"?>
+<ds:datastoreItem xmlns:ds="http://schemas.openxmlformats.org/officeDocument/2006/customXml" ds:itemID="{529E81E1-445C-4E91-8E35-C5BD736A3B77}">
+  <ds:schemaRefs>
+    <ds:schemaRef ds:uri="http://schemas.microsoft.com/sharepoint/v3/contenttype/forms"/>
+  </ds:schemaRefs>
+</ds:datastoreItem>
+</file>
+
+<file path=customXml/itemProps3.xml><?xml version="1.0" encoding="utf-8"?>
 <ds:datastoreItem xmlns:ds="http://schemas.openxmlformats.org/officeDocument/2006/customXml" ds:itemID="{C54E5144-405F-49D2-89C0-6C01A508B471}">
   <ds:schemaRefs>
     <ds:schemaRef ds:uri="http://schemas.microsoft.com/office/2006/metadata/contentType"/>
@@ -24965,12 +24974,4 @@
     <ds:schemaRef ds:uri="http://schemas.microsoft.com/internal/obd"/>
   </ds:schemaRefs>
 </ds:datastoreItem>
-</file>
-
-<file path=customXml/itemProps3.xml><?xml version="1.0" encoding="utf-8"?>
-<ds:datastoreItem xmlns:ds="http://schemas.openxmlformats.org/officeDocument/2006/customXml" ds:itemID="{529E81E1-445C-4E91-8E35-C5BD736A3B77}">
-  <ds:schemaRefs>
-    <ds:schemaRef ds:uri="http://schemas.microsoft.com/sharepoint/v3/contenttype/forms"/>
-  </ds:schemaRefs>
-</ds:datastoreItem>
 </file>
</xml_diff>